<commit_message>
Reposition around local-inventory access, not just coordination
The core problem isn't just fragmented WhatsApp/phone coordination — it's
that hard-to-find local inventory pushes international developers to
import their own equipment, keeping money and jobs off the island. Updates:

- README: lead with this framing, problem -> solution -> "trades and
  materials are next" vision, link to buildrelay.co
- Pitch deck slide 2 (The Problem): body copy now names the import
  substitution effect, not just coordination chaos
- Pitch deck slide 3 (The Insight): reframed from "meet contractors on
  WhatsApp" to "unlock local inventory and the money stays home"

Co-Authored-By: Claude Sonnet 5 <noreply@anthropic.com>
</commit_message>
<xml_diff>
--- a/relay-pitch-deck.pptx
+++ b/relay-pitch-deck.pptx
@@ -3423,7 +3423,7 @@
                 <a:ea typeface="Arial" pitchFamily="34" charset="-122"/>
                 <a:cs typeface="Arial" pitchFamily="34" charset="-120"/>
               </a:rPr>
-              <a:t>Equipment sits idle while nearby job sites stall. Trades get booked inefficiently. Deliveries are delayed. The industry loses millions annually to a problem that is entirely solvable.</a:t>
+              <a:t>Equipment sits idle while nearby job sites stall. Local inventory is so hard to find that international developers import their own equipment instead — keeping money and jobs off the island. Entirely solvable.</a:t>
             </a:r>
             <a:endParaRPr lang="en-US" sz="1600" dirty="0"/>
           </a:p>
@@ -3635,7 +3635,7 @@
                 <a:ea typeface="Arial" pitchFamily="34" charset="-122"/>
                 <a:cs typeface="Arial" pitchFamily="34" charset="-120"/>
               </a:rPr>
-              <a:t>The solution was already in their pocket</a:t>
+              <a:t>The equipment was already on the island</a:t>
             </a:r>
             <a:endParaRPr lang="en-US" sz="3400" dirty="0"/>
           </a:p>
@@ -3719,7 +3719,7 @@
                 <a:ea typeface="Arial" pitchFamily="34" charset="-122"/>
                 <a:cs typeface="Arial" pitchFamily="34" charset="-120"/>
               </a:rPr>
-              <a:t>Caribbean contractors are on WhatsApp and SMS all day. The coordination problem is not that people will not use technology — it is that no technology meets them where they already are.</a:t>
+              <a:t>Barbados already has the excavators, generators, and trucks contractors need — sitting idle because there was no fast way to find or book them. That gap, not a lack of equipment, is what pushes developers to import instead.</a:t>
             </a:r>
             <a:endParaRPr lang="en-US" sz="1900" dirty="0"/>
           </a:p>
@@ -3754,7 +3754,7 @@
                 <a:ea typeface="Arial" pitchFamily="34" charset="-122"/>
                 <a:cs typeface="Arial" pitchFamily="34" charset="-120"/>
               </a:rPr>
-              <a:t>Relay does not ask contractors to change how they work. It makes how they already work actually work.</a:t>
+              <a:t>Relay closes that gap: when local inventory is as easy to book as a text, equipment stays working and the money stays in the Caribbean.</a:t>
             </a:r>
             <a:endParaRPr lang="en-US" sz="1900" dirty="0"/>
           </a:p>

</xml_diff>

<commit_message>
Replace bottom-up revenue math with top-down market sizing
Slide 7 previously projected revenue from a single assumed scenario
(10 bookings/day at $1,500 avg). Replaced with a top-down funnel that's
easier for investors to sanity-check:

Total market ($1.5B-$2.0B) -> Addressable market ($20-30M) ->
Fee revenue potential ($1-3M) -> Year 1 target ($150,000)

Also updated the fee split from 15% to 10% (both the chart's cached
values and its embedded workbook, so "Edit Data" in PowerPoint stays
consistent) to match the new 10% platform fee.

Co-Authored-By: Claude Sonnet 5 <noreply@anthropic.com>
</commit_message>
<xml_diff>
--- a/relay-pitch-deck.pptx
+++ b/relay-pitch-deck.pptx
@@ -528,10 +528,10 @@
               <c:numCache>
                 <c:ptCount val="2"/>
                 <c:pt idx="0">
-                  <c:v>85</c:v>
+                  <c:v>90</c:v>
                 </c:pt>
                 <c:pt idx="1">
-                  <c:v>15</c:v>
+                  <c:v>10</c:v>
                 </c:pt>
               </c:numCache>
             </c:numRef>
@@ -5870,7 +5870,7 @@
                 <a:ea typeface="Arial" pitchFamily="34" charset="-122"/>
                 <a:cs typeface="Arial" pitchFamily="34" charset="-120"/>
               </a:rPr>
-              <a:t>85%  Owner payout</a:t>
+              <a:t>90%  Owner payout</a:t>
             </a:r>
             <a:endParaRPr lang="en-US" sz="1500" dirty="0"/>
           </a:p>
@@ -5929,7 +5929,7 @@
                 <a:ea typeface="Arial" pitchFamily="34" charset="-122"/>
                 <a:cs typeface="Arial" pitchFamily="34" charset="-120"/>
               </a:rPr>
-              <a:t>15%  Relay fee</a:t>
+              <a:t>10%  Relay fee</a:t>
             </a:r>
             <a:endParaRPr lang="en-US" sz="1500" dirty="0"/>
           </a:p>
@@ -6060,7 +6060,7 @@
                 <a:ea typeface="Arial" pitchFamily="34" charset="-122"/>
                 <a:cs typeface="Arial" pitchFamily="34" charset="-120"/>
               </a:rPr>
-              <a:t>THE MATH</a:t>
+              <a:t>MARKET SIZING</a:t>
             </a:r>
             <a:endParaRPr lang="en-US" sz="1300" dirty="0"/>
           </a:p>
@@ -6099,7 +6099,7 @@
                 <a:ea typeface="Arial" pitchFamily="34" charset="-122"/>
                 <a:cs typeface="Arial" pitchFamily="34" charset="-120"/>
               </a:rPr>
-              <a:t>Average booking</a:t>
+              <a:t>Total market</a:t>
             </a:r>
             <a:endParaRPr lang="en-US" sz="1400" dirty="0"/>
           </a:p>
@@ -6138,7 +6138,7 @@
                 <a:ea typeface="Arial" pitchFamily="34" charset="-122"/>
                 <a:cs typeface="Arial" pitchFamily="34" charset="-120"/>
               </a:rPr>
-              <a:t>$1,500</a:t>
+              <a:t>$1.5B–$2.0B</a:t>
             </a:r>
             <a:endParaRPr lang="en-US" sz="1400" dirty="0"/>
           </a:p>
@@ -6177,7 +6177,7 @@
                 <a:ea typeface="Arial" pitchFamily="34" charset="-122"/>
                 <a:cs typeface="Arial" pitchFamily="34" charset="-120"/>
               </a:rPr>
-              <a:t>Relay fee (15%)</a:t>
+              <a:t>Addressable market</a:t>
             </a:r>
             <a:endParaRPr lang="en-US" sz="1400" dirty="0"/>
           </a:p>
@@ -6216,7 +6216,7 @@
                 <a:ea typeface="Arial" pitchFamily="34" charset="-122"/>
                 <a:cs typeface="Arial" pitchFamily="34" charset="-120"/>
               </a:rPr>
-              <a:t>$225</a:t>
+              <a:t>$20M–$30M</a:t>
             </a:r>
             <a:endParaRPr lang="en-US" sz="1400" dirty="0"/>
           </a:p>
@@ -6255,7 +6255,7 @@
                 <a:ea typeface="Arial" pitchFamily="34" charset="-122"/>
                 <a:cs typeface="Arial" pitchFamily="34" charset="-120"/>
               </a:rPr>
-              <a:t>10 bookings / day</a:t>
+              <a:t>Fee revenue potential</a:t>
             </a:r>
             <a:endParaRPr lang="en-US" sz="1400" dirty="0"/>
           </a:p>
@@ -6294,7 +6294,7 @@
                 <a:ea typeface="Arial" pitchFamily="34" charset="-122"/>
                 <a:cs typeface="Arial" pitchFamily="34" charset="-120"/>
               </a:rPr>
-              <a:t>$2,250 daily</a:t>
+              <a:t>$1M–$3M</a:t>
             </a:r>
             <a:endParaRPr lang="en-US" sz="1400" dirty="0"/>
           </a:p>
@@ -6333,7 +6333,7 @@
                 <a:ea typeface="Arial" pitchFamily="34" charset="-122"/>
                 <a:cs typeface="Arial" pitchFamily="34" charset="-120"/>
               </a:rPr>
-              <a:t>ANNUALIZED</a:t>
+              <a:t>YEAR 1 TARGET</a:t>
             </a:r>
             <a:endParaRPr lang="en-US" sz="1400" dirty="0"/>
           </a:p>
@@ -6372,7 +6372,7 @@
                 <a:ea typeface="Arial" pitchFamily="34" charset="-122"/>
                 <a:cs typeface="Arial" pitchFamily="34" charset="-120"/>
               </a:rPr>
-              <a:t>$820,000</a:t>
+              <a:t>$150,000</a:t>
             </a:r>
             <a:endParaRPr lang="en-US" sz="3800" dirty="0"/>
           </a:p>

</xml_diff>

<commit_message>
Set the Relay wordmark/logo text to Space Grotesk, everything else stays Arial
Scoped precisely to the logo-mark text runs only: the cover slide's big
"Relay Digital" title, and each slide's small "RELAY DIGITAL" eyebrow +
"RELAY" footer mark. All titles, body copy, and stats remain Arial —
verified via a full text-content diff (zero differences) and visual
render that only those specific runs changed font.

Co-Authored-By: Claude Sonnet 5 <noreply@anthropic.com>
</commit_message>
<xml_diff>
--- a/relay-pitch-deck.pptx
+++ b/relay-pitch-deck.pptx
@@ -2225,9 +2225,9 @@
                 <a:solidFill>
                   <a:srgbClr val="FFFFFF"/>
                 </a:solidFill>
-                <a:latin typeface="Arial" pitchFamily="34" charset="0"/>
-                <a:ea typeface="Arial" pitchFamily="34" charset="-122"/>
-                <a:cs typeface="Arial" pitchFamily="34" charset="-120"/>
+                <a:latin typeface="Space Grotesk" pitchFamily="34" charset="0"/>
+                <a:ea typeface="Space Grotesk" pitchFamily="34" charset="-122"/>
+                <a:cs typeface="Space Grotesk" pitchFamily="34" charset="-120"/>
               </a:rPr>
               <a:t>Relay Digital</a:t>
             </a:r>
@@ -2398,9 +2398,9 @@
                 <a:solidFill>
                   <a:srgbClr val="ABABA5"/>
                 </a:solidFill>
-                <a:latin typeface="Arial" pitchFamily="34" charset="0"/>
-                <a:ea typeface="Arial" pitchFamily="34" charset="-122"/>
-                <a:cs typeface="Arial" pitchFamily="34" charset="-120"/>
+                <a:latin typeface="Space Grotesk" pitchFamily="34" charset="0"/>
+                <a:ea typeface="Space Grotesk" pitchFamily="34" charset="-122"/>
+                <a:cs typeface="Space Grotesk" pitchFamily="34" charset="-120"/>
               </a:rPr>
               <a:t>RELAY DIGITAL</a:t>
             </a:r>
@@ -2476,9 +2476,9 @@
                 <a:solidFill>
                   <a:srgbClr val="ABABA5"/>
                 </a:solidFill>
-                <a:latin typeface="Arial" pitchFamily="34" charset="0"/>
-                <a:ea typeface="Arial" pitchFamily="34" charset="-122"/>
-                <a:cs typeface="Arial" pitchFamily="34" charset="-120"/>
+                <a:latin typeface="Space Grotesk" pitchFamily="34" charset="0"/>
+                <a:ea typeface="Space Grotesk" pitchFamily="34" charset="-122"/>
+                <a:cs typeface="Space Grotesk" pitchFamily="34" charset="-120"/>
               </a:rPr>
               <a:t>RELAY</a:t>
             </a:r>
@@ -2951,9 +2951,9 @@
                 <a:solidFill>
                   <a:srgbClr val="ABABA5"/>
                 </a:solidFill>
-                <a:latin typeface="Arial" pitchFamily="34" charset="0"/>
-                <a:ea typeface="Arial" pitchFamily="34" charset="-122"/>
-                <a:cs typeface="Arial" pitchFamily="34" charset="-120"/>
+                <a:latin typeface="Space Grotesk" pitchFamily="34" charset="0"/>
+                <a:ea typeface="Space Grotesk" pitchFamily="34" charset="-122"/>
+                <a:cs typeface="Space Grotesk" pitchFamily="34" charset="-120"/>
               </a:rPr>
               <a:t>RELAY DIGITAL</a:t>
             </a:r>
@@ -3029,9 +3029,9 @@
                 <a:solidFill>
                   <a:srgbClr val="ABABA5"/>
                 </a:solidFill>
-                <a:latin typeface="Arial" pitchFamily="34" charset="0"/>
-                <a:ea typeface="Arial" pitchFamily="34" charset="-122"/>
-                <a:cs typeface="Arial" pitchFamily="34" charset="-120"/>
+                <a:latin typeface="Space Grotesk" pitchFamily="34" charset="0"/>
+                <a:ea typeface="Space Grotesk" pitchFamily="34" charset="-122"/>
+                <a:cs typeface="Space Grotesk" pitchFamily="34" charset="-120"/>
               </a:rPr>
               <a:t>RELAY</a:t>
             </a:r>
@@ -3514,9 +3514,9 @@
                 <a:solidFill>
                   <a:srgbClr val="ABABA5"/>
                 </a:solidFill>
-                <a:latin typeface="Arial" pitchFamily="34" charset="0"/>
-                <a:ea typeface="Arial" pitchFamily="34" charset="-122"/>
-                <a:cs typeface="Arial" pitchFamily="34" charset="-120"/>
+                <a:latin typeface="Space Grotesk" pitchFamily="34" charset="0"/>
+                <a:ea typeface="Space Grotesk" pitchFamily="34" charset="-122"/>
+                <a:cs typeface="Space Grotesk" pitchFamily="34" charset="-120"/>
               </a:rPr>
               <a:t>RELAY DIGITAL</a:t>
             </a:r>
@@ -3592,9 +3592,9 @@
                 <a:solidFill>
                   <a:srgbClr val="ABABA5"/>
                 </a:solidFill>
-                <a:latin typeface="Arial" pitchFamily="34" charset="0"/>
-                <a:ea typeface="Arial" pitchFamily="34" charset="-122"/>
-                <a:cs typeface="Arial" pitchFamily="34" charset="-120"/>
+                <a:latin typeface="Space Grotesk" pitchFamily="34" charset="0"/>
+                <a:ea typeface="Space Grotesk" pitchFamily="34" charset="-122"/>
+                <a:cs typeface="Space Grotesk" pitchFamily="34" charset="-120"/>
               </a:rPr>
               <a:t>RELAY</a:t>
             </a:r>
@@ -3845,9 +3845,9 @@
                 <a:solidFill>
                   <a:srgbClr val="ABABA5"/>
                 </a:solidFill>
-                <a:latin typeface="Arial" pitchFamily="34" charset="0"/>
-                <a:ea typeface="Arial" pitchFamily="34" charset="-122"/>
-                <a:cs typeface="Arial" pitchFamily="34" charset="-120"/>
+                <a:latin typeface="Space Grotesk" pitchFamily="34" charset="0"/>
+                <a:ea typeface="Space Grotesk" pitchFamily="34" charset="-122"/>
+                <a:cs typeface="Space Grotesk" pitchFamily="34" charset="-120"/>
               </a:rPr>
               <a:t>RELAY DIGITAL</a:t>
             </a:r>
@@ -3923,9 +3923,9 @@
                 <a:solidFill>
                   <a:srgbClr val="ABABA5"/>
                 </a:solidFill>
-                <a:latin typeface="Arial" pitchFamily="34" charset="0"/>
-                <a:ea typeface="Arial" pitchFamily="34" charset="-122"/>
-                <a:cs typeface="Arial" pitchFamily="34" charset="-120"/>
+                <a:latin typeface="Space Grotesk" pitchFamily="34" charset="0"/>
+                <a:ea typeface="Space Grotesk" pitchFamily="34" charset="-122"/>
+                <a:cs typeface="Space Grotesk" pitchFamily="34" charset="-120"/>
               </a:rPr>
               <a:t>RELAY</a:t>
             </a:r>
@@ -4379,9 +4379,9 @@
                 <a:solidFill>
                   <a:srgbClr val="ABABA5"/>
                 </a:solidFill>
-                <a:latin typeface="Arial" pitchFamily="34" charset="0"/>
-                <a:ea typeface="Arial" pitchFamily="34" charset="-122"/>
-                <a:cs typeface="Arial" pitchFamily="34" charset="-120"/>
+                <a:latin typeface="Space Grotesk" pitchFamily="34" charset="0"/>
+                <a:ea typeface="Space Grotesk" pitchFamily="34" charset="-122"/>
+                <a:cs typeface="Space Grotesk" pitchFamily="34" charset="-120"/>
               </a:rPr>
               <a:t>RELAY DIGITAL</a:t>
             </a:r>
@@ -4457,9 +4457,9 @@
                 <a:solidFill>
                   <a:srgbClr val="ABABA5"/>
                 </a:solidFill>
-                <a:latin typeface="Arial" pitchFamily="34" charset="0"/>
-                <a:ea typeface="Arial" pitchFamily="34" charset="-122"/>
-                <a:cs typeface="Arial" pitchFamily="34" charset="-120"/>
+                <a:latin typeface="Space Grotesk" pitchFamily="34" charset="0"/>
+                <a:ea typeface="Space Grotesk" pitchFamily="34" charset="-122"/>
+                <a:cs typeface="Space Grotesk" pitchFamily="34" charset="-120"/>
               </a:rPr>
               <a:t>RELAY</a:t>
             </a:r>
@@ -5223,9 +5223,9 @@
                 <a:solidFill>
                   <a:srgbClr val="ABABA5"/>
                 </a:solidFill>
-                <a:latin typeface="Arial" pitchFamily="34" charset="0"/>
-                <a:ea typeface="Arial" pitchFamily="34" charset="-122"/>
-                <a:cs typeface="Arial" pitchFamily="34" charset="-120"/>
+                <a:latin typeface="Space Grotesk" pitchFamily="34" charset="0"/>
+                <a:ea typeface="Space Grotesk" pitchFamily="34" charset="-122"/>
+                <a:cs typeface="Space Grotesk" pitchFamily="34" charset="-120"/>
               </a:rPr>
               <a:t>RELAY DIGITAL</a:t>
             </a:r>
@@ -5301,9 +5301,9 @@
                 <a:solidFill>
                   <a:srgbClr val="ABABA5"/>
                 </a:solidFill>
-                <a:latin typeface="Arial" pitchFamily="34" charset="0"/>
-                <a:ea typeface="Arial" pitchFamily="34" charset="-122"/>
-                <a:cs typeface="Arial" pitchFamily="34" charset="-120"/>
+                <a:latin typeface="Space Grotesk" pitchFamily="34" charset="0"/>
+                <a:ea typeface="Space Grotesk" pitchFamily="34" charset="-122"/>
+                <a:cs typeface="Space Grotesk" pitchFamily="34" charset="-120"/>
               </a:rPr>
               <a:t>RELAY</a:t>
             </a:r>
@@ -5635,9 +5635,9 @@
                 <a:solidFill>
                   <a:srgbClr val="ABABA5"/>
                 </a:solidFill>
-                <a:latin typeface="Arial" pitchFamily="34" charset="0"/>
-                <a:ea typeface="Arial" pitchFamily="34" charset="-122"/>
-                <a:cs typeface="Arial" pitchFamily="34" charset="-120"/>
+                <a:latin typeface="Space Grotesk" pitchFamily="34" charset="0"/>
+                <a:ea typeface="Space Grotesk" pitchFamily="34" charset="-122"/>
+                <a:cs typeface="Space Grotesk" pitchFamily="34" charset="-120"/>
               </a:rPr>
               <a:t>RELAY DIGITAL</a:t>
             </a:r>
@@ -5713,9 +5713,9 @@
                 <a:solidFill>
                   <a:srgbClr val="ABABA5"/>
                 </a:solidFill>
-                <a:latin typeface="Arial" pitchFamily="34" charset="0"/>
-                <a:ea typeface="Arial" pitchFamily="34" charset="-122"/>
-                <a:cs typeface="Arial" pitchFamily="34" charset="-120"/>
+                <a:latin typeface="Space Grotesk" pitchFamily="34" charset="0"/>
+                <a:ea typeface="Space Grotesk" pitchFamily="34" charset="-122"/>
+                <a:cs typeface="Space Grotesk" pitchFamily="34" charset="-120"/>
               </a:rPr>
               <a:t>RELAY</a:t>
             </a:r>
@@ -6463,9 +6463,9 @@
                 <a:solidFill>
                   <a:srgbClr val="ABABA5"/>
                 </a:solidFill>
-                <a:latin typeface="Arial" pitchFamily="34" charset="0"/>
-                <a:ea typeface="Arial" pitchFamily="34" charset="-122"/>
-                <a:cs typeface="Arial" pitchFamily="34" charset="-120"/>
+                <a:latin typeface="Space Grotesk" pitchFamily="34" charset="0"/>
+                <a:ea typeface="Space Grotesk" pitchFamily="34" charset="-122"/>
+                <a:cs typeface="Space Grotesk" pitchFamily="34" charset="-120"/>
               </a:rPr>
               <a:t>RELAY DIGITAL</a:t>
             </a:r>
@@ -6541,9 +6541,9 @@
                 <a:solidFill>
                   <a:srgbClr val="ABABA5"/>
                 </a:solidFill>
-                <a:latin typeface="Arial" pitchFamily="34" charset="0"/>
-                <a:ea typeface="Arial" pitchFamily="34" charset="-122"/>
-                <a:cs typeface="Arial" pitchFamily="34" charset="-120"/>
+                <a:latin typeface="Space Grotesk" pitchFamily="34" charset="0"/>
+                <a:ea typeface="Space Grotesk" pitchFamily="34" charset="-122"/>
+                <a:cs typeface="Space Grotesk" pitchFamily="34" charset="-120"/>
               </a:rPr>
               <a:t>RELAY</a:t>
             </a:r>
@@ -7352,9 +7352,9 @@
                 <a:solidFill>
                   <a:srgbClr val="ABABA5"/>
                 </a:solidFill>
-                <a:latin typeface="Arial" pitchFamily="34" charset="0"/>
-                <a:ea typeface="Arial" pitchFamily="34" charset="-122"/>
-                <a:cs typeface="Arial" pitchFamily="34" charset="-120"/>
+                <a:latin typeface="Space Grotesk" pitchFamily="34" charset="0"/>
+                <a:ea typeface="Space Grotesk" pitchFamily="34" charset="-122"/>
+                <a:cs typeface="Space Grotesk" pitchFamily="34" charset="-120"/>
               </a:rPr>
               <a:t>RELAY DIGITAL</a:t>
             </a:r>
@@ -7430,9 +7430,9 @@
                 <a:solidFill>
                   <a:srgbClr val="ABABA5"/>
                 </a:solidFill>
-                <a:latin typeface="Arial" pitchFamily="34" charset="0"/>
-                <a:ea typeface="Arial" pitchFamily="34" charset="-122"/>
-                <a:cs typeface="Arial" pitchFamily="34" charset="-120"/>
+                <a:latin typeface="Space Grotesk" pitchFamily="34" charset="0"/>
+                <a:ea typeface="Space Grotesk" pitchFamily="34" charset="-122"/>
+                <a:cs typeface="Space Grotesk" pitchFamily="34" charset="-120"/>
               </a:rPr>
               <a:t>RELAY</a:t>
             </a:r>

</xml_diff>